<commit_message>
Point the website deck at links that stay online.
The previous suggestion address expired after about an hour.

Co-authored-by: DanLejerskar <DanLejerskar@users.noreply.github.com>
</commit_message>
<xml_diff>
--- a/eon-product-overview/eon-reality-website-structure.pptx
+++ b/eon-product-overview/eon-reality-website-structure.pptx
@@ -6668,7 +6668,7 @@
                 <a:ea typeface="Calibri" pitchFamily="34" charset="-122"/>
                 <a:cs typeface="Calibri" pitchFamily="34" charset="-120"/>
               </a:rPr>
-              <a:t>This is a preview</a:t>
+              <a:t>This is a draft</a:t>
             </a:r>
             <a:endParaRPr lang="en-US" sz="1500" dirty="0"/>
           </a:p>
@@ -6707,7 +6707,7 @@
                 <a:ea typeface="Calibri" pitchFamily="34" charset="-122"/>
                 <a:cs typeface="Calibri" pitchFamily="34" charset="-120"/>
               </a:rPr>
-              <a:t>The suggestion link is a preview of the menu. It is not eonreality.com, and the platform is not the finished product.</a:t>
+              <a:t>The suggestion is a draft of the menu. It is not eonreality.com, and the platform is not the finished product.</a:t>
             </a:r>
             <a:endParaRPr lang="en-US" sz="1300" dirty="0"/>
           </a:p>
@@ -7042,7 +7042,7 @@
                 <a:ea typeface="Calibri" pitchFamily="34" charset="-122"/>
                 <a:cs typeface="Calibri" pitchFamily="34" charset="-120"/>
               </a:rPr>
-              <a:t>The new short menu. Public for about an hour.</a:t>
+              <a:t>The new short menu. This link stays up.</a:t>
             </a:r>
             <a:endParaRPr lang="en-US" sz="1300" dirty="0"/>
           </a:p>
@@ -7090,7 +7090,7 @@
                   </a:extLst>
                 </a:hlinkClick>
               </a:rPr>
-              <a:t>temporary-sonic-indigo-vj9wu0l.vercel.app</a:t>
+              <a:t>Open the menu</a:t>
             </a:r>
             <a:endParaRPr lang="en-US" sz="1400" dirty="0"/>
           </a:p>
@@ -7158,7 +7158,7 @@
                 <a:ea typeface="Calibri" pitchFamily="34" charset="-122"/>
                 <a:cs typeface="Calibri" pitchFamily="34" charset="-120"/>
               </a:rPr>
-              <a:t>Same page, signed in</a:t>
+              <a:t>PowerPoint</a:t>
             </a:r>
             <a:endParaRPr lang="en-US" sz="1600" dirty="0"/>
           </a:p>
@@ -7197,7 +7197,7 @@
                 <a:ea typeface="Calibri" pitchFamily="34" charset="-122"/>
                 <a:cs typeface="Calibri" pitchFamily="34" charset="-120"/>
               </a:rPr>
-              <a:t>The lasting preview on the existing project.</a:t>
+              <a:t>Structure, what to keep, what to remove, and the cover note.</a:t>
             </a:r>
             <a:endParaRPr lang="en-US" sz="1300" dirty="0"/>
           </a:p>
@@ -7245,31 +7245,7 @@
                   </a:extLst>
                 </a:hlinkClick>
               </a:rPr>
-              <a:t>Open /eon-product-overview/</a:t>
-            </a:r>
-            <a:endParaRPr lang="en-US" sz="1400" dirty="0"/>
-          </a:p>
-          <a:p>
-            <a:pPr indent="0" marL="0">
-              <a:buNone/>
-            </a:pPr>
-            <a:r>
-              <a:rPr lang="en-US" sz="1400" u="sng" dirty="0">
-                <a:solidFill>
-                  <a:srgbClr val="9A1F3D"/>
-                </a:solidFill>
-                <a:latin typeface="Calibri" pitchFamily="34" charset="0"/>
-                <a:ea typeface="Calibri" pitchFamily="34" charset="-122"/>
-                <a:cs typeface="Calibri" pitchFamily="34" charset="-120"/>
-                <a:hlinkClick r:id="rId2" invalidUrl="" action="" tgtFrame="" tooltip="" history="1" highlightClick="0" endSnd="0">
-                  <a:extLst>
-                    <a:ext uri="{A12FA001-AC4F-418D-AE19-62706E023703}">
-                      <ahyp:hlinkClr xmlns:ahyp="http://schemas.microsoft.com/office/drawing/2018/hyperlinkcolor" val="tx"/>
-                    </a:ext>
-                  </a:extLst>
-                </a:hlinkClick>
-              </a:rPr>
-              <a:t>on the field-iq-walkthrough preview</a:t>
+              <a:t>Download the PowerPoint</a:t>
             </a:r>
             <a:endParaRPr lang="en-US" sz="1400" dirty="0"/>
           </a:p>
@@ -7424,31 +7400,7 @@
                   </a:extLst>
                 </a:hlinkClick>
               </a:rPr>
-              <a:t>eon-education-government-review</a:t>
-            </a:r>
-            <a:endParaRPr lang="en-US" sz="1400" dirty="0"/>
-          </a:p>
-          <a:p>
-            <a:pPr indent="0" marL="0">
-              <a:buNone/>
-            </a:pPr>
-            <a:r>
-              <a:rPr lang="en-US" sz="1400" u="sng" dirty="0">
-                <a:solidFill>
-                  <a:srgbClr val="9A1F3D"/>
-                </a:solidFill>
-                <a:latin typeface="Calibri" pitchFamily="34" charset="0"/>
-                <a:ea typeface="Calibri" pitchFamily="34" charset="-122"/>
-                <a:cs typeface="Calibri" pitchFamily="34" charset="-120"/>
-                <a:hlinkClick r:id="rId3" invalidUrl="" action="" tgtFrame="" tooltip="" history="1" highlightClick="0" endSnd="0">
-                  <a:extLst>
-                    <a:ext uri="{A12FA001-AC4F-418D-AE19-62706E023703}">
-                      <ahyp:hlinkClr xmlns:ahyp="http://schemas.microsoft.com/office/drawing/2018/hyperlinkcolor" val="tx"/>
-                    </a:ext>
-                  </a:extLst>
-                </a:hlinkClick>
-              </a:rPr>
-              <a:t>.vercel.app/#products</a:t>
+              <a:t>Open the platform</a:t>
             </a:r>
             <a:endParaRPr lang="en-US" sz="1400" dirty="0"/>
           </a:p>
@@ -7603,7 +7555,7 @@
                   </a:extLst>
                 </a:hlinkClick>
               </a:rPr>
-              <a:t>eonglobalcampus.com</a:t>
+              <a:t>Open the campus</a:t>
             </a:r>
             <a:endParaRPr lang="en-US" sz="1400" dirty="0"/>
           </a:p>
@@ -8008,8 +7960,79 @@
                 <a:ea typeface="Calibri" pitchFamily="34" charset="-122"/>
                 <a:cs typeface="Calibri" pitchFamily="34" charset="-120"/>
               </a:rPr>
-              <a:t>Please open the suggestion: https://temporary-sonic-indigo-vj9wu0l.vercel.app</a:t>
-            </a:r>
+              <a:t>Please open the suggestion: </a:t>
+            </a:r>
+            <a:endParaRPr lang="en-US" sz="1400" dirty="0"/>
+          </a:p>
+          <a:p>
+            <a:pPr indent="0" marL="0">
+              <a:buNone/>
+            </a:pPr>
+            <a:r>
+              <a:rPr lang="en-US" sz="1400" u="sng" dirty="0">
+                <a:solidFill>
+                  <a:srgbClr val="9A1F3D"/>
+                </a:solidFill>
+                <a:latin typeface="Calibri" pitchFamily="34" charset="0"/>
+                <a:ea typeface="Calibri" pitchFamily="34" charset="-122"/>
+                <a:cs typeface="Calibri" pitchFamily="34" charset="-120"/>
+                <a:hlinkClick r:id="rId1" invalidUrl="" action="" tgtFrame="" tooltip="" history="1" highlightClick="0" endSnd="0">
+                  <a:extLst>
+                    <a:ext uri="{A12FA001-AC4F-418D-AE19-62706E023703}">
+                      <ahyp:hlinkClr xmlns:ahyp="http://schemas.microsoft.com/office/drawing/2018/hyperlinkcolor" val="tx"/>
+                    </a:ext>
+                  </a:extLst>
+                </a:hlinkClick>
+              </a:rPr>
+              <a:t>Open the menu</a:t>
+            </a:r>
+            <a:pPr indent="0" marL="0">
+              <a:buNone/>
+            </a:pPr>
+            <a:endParaRPr lang="en-US" sz="1400" dirty="0"/>
+          </a:p>
+          <a:p>
+            <a:pPr indent="0" marL="0">
+              <a:buNone/>
+            </a:pPr>
+            <a:r>
+              <a:rPr lang="en-US" sz="1400" dirty="0">
+                <a:solidFill>
+                  <a:srgbClr val="142033"/>
+                </a:solidFill>
+                <a:latin typeface="Calibri" pitchFamily="34" charset="0"/>
+                <a:ea typeface="Calibri" pitchFamily="34" charset="-122"/>
+                <a:cs typeface="Calibri" pitchFamily="34" charset="-120"/>
+              </a:rPr>
+              <a:t>And the PowerPoint: </a:t>
+            </a:r>
+            <a:endParaRPr lang="en-US" sz="1400" dirty="0"/>
+          </a:p>
+          <a:p>
+            <a:pPr indent="0" marL="0">
+              <a:buNone/>
+            </a:pPr>
+            <a:r>
+              <a:rPr lang="en-US" sz="1400" u="sng" dirty="0">
+                <a:solidFill>
+                  <a:srgbClr val="9A1F3D"/>
+                </a:solidFill>
+                <a:latin typeface="Calibri" pitchFamily="34" charset="0"/>
+                <a:ea typeface="Calibri" pitchFamily="34" charset="-122"/>
+                <a:cs typeface="Calibri" pitchFamily="34" charset="-120"/>
+                <a:hlinkClick r:id="rId2" invalidUrl="" action="" tgtFrame="" tooltip="" history="1" highlightClick="0" endSnd="0">
+                  <a:extLst>
+                    <a:ext uri="{A12FA001-AC4F-418D-AE19-62706E023703}">
+                      <ahyp:hlinkClr xmlns:ahyp="http://schemas.microsoft.com/office/drawing/2018/hyperlinkcolor" val="tx"/>
+                    </a:ext>
+                  </a:extLst>
+                </a:hlinkClick>
+              </a:rPr>
+              <a:t>Download the PowerPoint</a:t>
+            </a:r>
+            <a:pPr indent="0" marL="0">
+              <a:buNone/>
+            </a:pPr>
             <a:endParaRPr lang="en-US" sz="1400" dirty="0"/>
           </a:p>
           <a:p>

</xml_diff>